<commit_message>
Brand- show created data in datatable
</commit_message>
<xml_diff>
--- a/.lessons/58 Backend Product And Related Features/3 Brand- show created data in datatable/1.pptx
+++ b/.lessons/58 Backend Product And Related Features/3 Brand- show created data in datatable/1.pptx
@@ -7,7 +7,12 @@
   <p:sldIdLst>
     <p:sldId id="413" r:id="rId2"/>
     <p:sldId id="414" r:id="rId3"/>
-    <p:sldId id="400" r:id="rId4"/>
+    <p:sldId id="416" r:id="rId4"/>
+    <p:sldId id="415" r:id="rId5"/>
+    <p:sldId id="417" r:id="rId6"/>
+    <p:sldId id="418" r:id="rId7"/>
+    <p:sldId id="419" r:id="rId8"/>
+    <p:sldId id="400" r:id="rId9"/>
   </p:sldIdLst>
   <p:sldSz cx="12192000" cy="6858000"/>
   <p:notesSz cx="6858000" cy="9144000"/>
@@ -261,7 +266,7 @@
           <a:p>
             <a:fld id="{3E102D2E-813C-461C-9963-687A650C48C0}" type="datetimeFigureOut">
               <a:rPr lang="en-US" smtClean="0"/>
-              <a:t>6/26/2025</a:t>
+              <a:t>9/8/2025</a:t>
             </a:fld>
             <a:endParaRPr lang="en-US"/>
           </a:p>
@@ -459,7 +464,7 @@
           <a:p>
             <a:fld id="{3E102D2E-813C-461C-9963-687A650C48C0}" type="datetimeFigureOut">
               <a:rPr lang="en-US" smtClean="0"/>
-              <a:t>6/26/2025</a:t>
+              <a:t>9/8/2025</a:t>
             </a:fld>
             <a:endParaRPr lang="en-US"/>
           </a:p>
@@ -667,7 +672,7 @@
           <a:p>
             <a:fld id="{3E102D2E-813C-461C-9963-687A650C48C0}" type="datetimeFigureOut">
               <a:rPr lang="en-US" smtClean="0"/>
-              <a:t>6/26/2025</a:t>
+              <a:t>9/8/2025</a:t>
             </a:fld>
             <a:endParaRPr lang="en-US"/>
           </a:p>
@@ -865,7 +870,7 @@
           <a:p>
             <a:fld id="{3E102D2E-813C-461C-9963-687A650C48C0}" type="datetimeFigureOut">
               <a:rPr lang="en-US" smtClean="0"/>
-              <a:t>6/26/2025</a:t>
+              <a:t>9/8/2025</a:t>
             </a:fld>
             <a:endParaRPr lang="en-US"/>
           </a:p>
@@ -1140,7 +1145,7 @@
           <a:p>
             <a:fld id="{3E102D2E-813C-461C-9963-687A650C48C0}" type="datetimeFigureOut">
               <a:rPr lang="en-US" smtClean="0"/>
-              <a:t>6/26/2025</a:t>
+              <a:t>9/8/2025</a:t>
             </a:fld>
             <a:endParaRPr lang="en-US"/>
           </a:p>
@@ -1405,7 +1410,7 @@
           <a:p>
             <a:fld id="{3E102D2E-813C-461C-9963-687A650C48C0}" type="datetimeFigureOut">
               <a:rPr lang="en-US" smtClean="0"/>
-              <a:t>6/26/2025</a:t>
+              <a:t>9/8/2025</a:t>
             </a:fld>
             <a:endParaRPr lang="en-US"/>
           </a:p>
@@ -1817,7 +1822,7 @@
           <a:p>
             <a:fld id="{3E102D2E-813C-461C-9963-687A650C48C0}" type="datetimeFigureOut">
               <a:rPr lang="en-US" smtClean="0"/>
-              <a:t>6/26/2025</a:t>
+              <a:t>9/8/2025</a:t>
             </a:fld>
             <a:endParaRPr lang="en-US"/>
           </a:p>
@@ -1958,7 +1963,7 @@
           <a:p>
             <a:fld id="{3E102D2E-813C-461C-9963-687A650C48C0}" type="datetimeFigureOut">
               <a:rPr lang="en-US" smtClean="0"/>
-              <a:t>6/26/2025</a:t>
+              <a:t>9/8/2025</a:t>
             </a:fld>
             <a:endParaRPr lang="en-US"/>
           </a:p>
@@ -2071,7 +2076,7 @@
           <a:p>
             <a:fld id="{3E102D2E-813C-461C-9963-687A650C48C0}" type="datetimeFigureOut">
               <a:rPr lang="en-US" smtClean="0"/>
-              <a:t>6/26/2025</a:t>
+              <a:t>9/8/2025</a:t>
             </a:fld>
             <a:endParaRPr lang="en-US"/>
           </a:p>
@@ -2382,7 +2387,7 @@
           <a:p>
             <a:fld id="{3E102D2E-813C-461C-9963-687A650C48C0}" type="datetimeFigureOut">
               <a:rPr lang="en-US" smtClean="0"/>
-              <a:t>6/26/2025</a:t>
+              <a:t>9/8/2025</a:t>
             </a:fld>
             <a:endParaRPr lang="en-US"/>
           </a:p>
@@ -2670,7 +2675,7 @@
           <a:p>
             <a:fld id="{3E102D2E-813C-461C-9963-687A650C48C0}" type="datetimeFigureOut">
               <a:rPr lang="en-US" smtClean="0"/>
-              <a:t>6/26/2025</a:t>
+              <a:t>9/8/2025</a:t>
             </a:fld>
             <a:endParaRPr lang="en-US"/>
           </a:p>
@@ -2911,7 +2916,7 @@
           <a:p>
             <a:fld id="{3E102D2E-813C-461C-9963-687A650C48C0}" type="datetimeFigureOut">
               <a:rPr lang="en-US" smtClean="0"/>
-              <a:t>6/26/2025</a:t>
+              <a:t>9/8/2025</a:t>
             </a:fld>
             <a:endParaRPr lang="en-US"/>
           </a:p>
@@ -3369,21 +3374,54 @@
               <a:buNone/>
             </a:pPr>
             <a:r>
-              <a:rPr kumimoji="0" lang="en-US" altLang="en-US" sz="1300" b="0" i="0" u="none" strike="noStrike" cap="none" normalizeH="0" baseline="0">
-                <a:ln>
-                  <a:noFill/>
-                </a:ln>
-                <a:solidFill>
-                  <a:schemeClr val="tx1"/>
-                </a:solidFill>
-                <a:effectLst/>
+              <a:rPr lang="en-US" altLang="en-US" sz="1300">
                 <a:latin typeface="Arial" panose="020B0604020202020204" pitchFamily="34" charset="0"/>
               </a:rPr>
-              <a:t>.</a:t>
-            </a:r>
-          </a:p>
-        </p:txBody>
-      </p:sp>
+              <a:t>app\DataTables\BrandDataTable.php</a:t>
+            </a:r>
+            <a:endParaRPr kumimoji="0" lang="en-US" altLang="en-US" sz="1300" b="0" i="0" u="none" strike="noStrike" cap="none" normalizeH="0" baseline="0">
+              <a:ln>
+                <a:noFill/>
+              </a:ln>
+              <a:solidFill>
+                <a:schemeClr val="tx1"/>
+              </a:solidFill>
+              <a:effectLst/>
+              <a:latin typeface="Arial" panose="020B0604020202020204" pitchFamily="34" charset="0"/>
+            </a:endParaRPr>
+          </a:p>
+        </p:txBody>
+      </p:sp>
+      <p:pic>
+        <p:nvPicPr>
+          <p:cNvPr id="6" name="Picture 5">
+            <a:extLst>
+              <a:ext uri="{FF2B5EF4-FFF2-40B4-BE49-F238E27FC236}">
+                <a16:creationId xmlns:a16="http://schemas.microsoft.com/office/drawing/2014/main" id="{772C28F4-ED75-C7CE-CC7A-D450E549BA1E}"/>
+              </a:ext>
+            </a:extLst>
+          </p:cNvPr>
+          <p:cNvPicPr>
+            <a:picLocks noChangeAspect="1"/>
+          </p:cNvPicPr>
+          <p:nvPr/>
+        </p:nvPicPr>
+        <p:blipFill>
+          <a:blip r:embed="rId2"/>
+          <a:stretch>
+            <a:fillRect/>
+          </a:stretch>
+        </p:blipFill>
+        <p:spPr>
+          <a:xfrm>
+            <a:off x="7609836" y="1666150"/>
+            <a:ext cx="4582164" cy="5191850"/>
+          </a:xfrm>
+          <a:prstGeom prst="rect">
+            <a:avLst/>
+          </a:prstGeom>
+        </p:spPr>
+      </p:pic>
     </p:spTree>
     <p:extLst>
       <p:ext uri="{BB962C8B-B14F-4D97-AF65-F5344CB8AC3E}">
@@ -3455,21 +3493,54 @@
               <a:buNone/>
             </a:pPr>
             <a:r>
-              <a:rPr kumimoji="0" lang="en-US" altLang="en-US" sz="1300" b="0" i="0" u="none" strike="noStrike" cap="none" normalizeH="0" baseline="0">
-                <a:ln>
-                  <a:noFill/>
-                </a:ln>
-                <a:solidFill>
-                  <a:schemeClr val="tx1"/>
-                </a:solidFill>
-                <a:effectLst/>
+              <a:rPr lang="en-US" altLang="en-US" sz="1300">
                 <a:latin typeface="Arial" panose="020B0604020202020204" pitchFamily="34" charset="0"/>
               </a:rPr>
-              <a:t>.</a:t>
-            </a:r>
-          </a:p>
-        </p:txBody>
-      </p:sp>
+              <a:t>app\DataTables\BrandDataTable.php</a:t>
+            </a:r>
+            <a:endParaRPr kumimoji="0" lang="en-US" altLang="en-US" sz="1300" b="0" i="0" u="none" strike="noStrike" cap="none" normalizeH="0" baseline="0">
+              <a:ln>
+                <a:noFill/>
+              </a:ln>
+              <a:solidFill>
+                <a:schemeClr val="tx1"/>
+              </a:solidFill>
+              <a:effectLst/>
+              <a:latin typeface="Arial" panose="020B0604020202020204" pitchFamily="34" charset="0"/>
+            </a:endParaRPr>
+          </a:p>
+        </p:txBody>
+      </p:sp>
+      <p:pic>
+        <p:nvPicPr>
+          <p:cNvPr id="4" name="Picture 3">
+            <a:extLst>
+              <a:ext uri="{FF2B5EF4-FFF2-40B4-BE49-F238E27FC236}">
+                <a16:creationId xmlns:a16="http://schemas.microsoft.com/office/drawing/2014/main" id="{E9EC571D-5AA6-AD2E-1770-45DF67745537}"/>
+              </a:ext>
+            </a:extLst>
+          </p:cNvPr>
+          <p:cNvPicPr>
+            <a:picLocks noChangeAspect="1"/>
+          </p:cNvPicPr>
+          <p:nvPr/>
+        </p:nvPicPr>
+        <p:blipFill>
+          <a:blip r:embed="rId2"/>
+          <a:stretch>
+            <a:fillRect/>
+          </a:stretch>
+        </p:blipFill>
+        <p:spPr>
+          <a:xfrm>
+            <a:off x="3629891" y="909848"/>
+            <a:ext cx="8562109" cy="5948151"/>
+          </a:xfrm>
+          <a:prstGeom prst="rect">
+            <a:avLst/>
+          </a:prstGeom>
+        </p:spPr>
+      </p:pic>
     </p:spTree>
     <p:extLst>
       <p:ext uri="{BB962C8B-B14F-4D97-AF65-F5344CB8AC3E}">
@@ -3484,6 +3555,503 @@
 </file>
 
 <file path=ppt/slides/slide3.xml><?xml version="1.0" encoding="utf-8"?>
+<p:sld xmlns:a="http://schemas.openxmlformats.org/drawingml/2006/main" xmlns:r="http://schemas.openxmlformats.org/officeDocument/2006/relationships" xmlns:p="http://schemas.openxmlformats.org/presentationml/2006/main">
+  <p:cSld>
+    <p:spTree>
+      <p:nvGrpSpPr>
+        <p:cNvPr id="1" name="">
+          <a:extLst>
+            <a:ext uri="{FF2B5EF4-FFF2-40B4-BE49-F238E27FC236}">
+              <a16:creationId xmlns:a16="http://schemas.microsoft.com/office/drawing/2014/main" id="{DF2AAE1A-09DD-E8CB-9900-7D0C9A0F8DB3}"/>
+            </a:ext>
+          </a:extLst>
+        </p:cNvPr>
+        <p:cNvGrpSpPr/>
+        <p:nvPr/>
+      </p:nvGrpSpPr>
+      <p:grpSpPr>
+        <a:xfrm>
+          <a:off x="0" y="0"/>
+          <a:ext cx="0" cy="0"/>
+          <a:chOff x="0" y="0"/>
+          <a:chExt cx="0" cy="0"/>
+        </a:xfrm>
+      </p:grpSpPr>
+      <p:sp>
+        <p:nvSpPr>
+          <p:cNvPr id="3" name="TextBox 2">
+            <a:extLst>
+              <a:ext uri="{FF2B5EF4-FFF2-40B4-BE49-F238E27FC236}">
+                <a16:creationId xmlns:a16="http://schemas.microsoft.com/office/drawing/2014/main" id="{22BDF6B4-B21D-32F2-B244-529FDF90FC1B}"/>
+              </a:ext>
+            </a:extLst>
+          </p:cNvPr>
+          <p:cNvSpPr txBox="1"/>
+          <p:nvPr/>
+        </p:nvSpPr>
+        <p:spPr>
+          <a:xfrm>
+            <a:off x="217714" y="255046"/>
+            <a:ext cx="11756571" cy="355354"/>
+          </a:xfrm>
+          <a:prstGeom prst="rect">
+            <a:avLst/>
+          </a:prstGeom>
+          <a:noFill/>
+        </p:spPr>
+        <p:txBody>
+          <a:bodyPr wrap="square">
+            <a:spAutoFit/>
+          </a:bodyPr>
+          <a:lstStyle/>
+          <a:p>
+            <a:pPr>
+              <a:lnSpc>
+                <a:spcPct val="150000"/>
+              </a:lnSpc>
+              <a:buNone/>
+            </a:pPr>
+            <a:r>
+              <a:rPr lang="en-US" altLang="en-US" sz="1300">
+                <a:latin typeface="Arial" panose="020B0604020202020204" pitchFamily="34" charset="0"/>
+              </a:rPr>
+              <a:t>app\DataTables\BrandDataTable.php</a:t>
+            </a:r>
+          </a:p>
+        </p:txBody>
+      </p:sp>
+      <p:pic>
+        <p:nvPicPr>
+          <p:cNvPr id="4" name="Picture 3">
+            <a:extLst>
+              <a:ext uri="{FF2B5EF4-FFF2-40B4-BE49-F238E27FC236}">
+                <a16:creationId xmlns:a16="http://schemas.microsoft.com/office/drawing/2014/main" id="{47004E9C-FE15-7112-24A9-C362C8ECD13D}"/>
+              </a:ext>
+            </a:extLst>
+          </p:cNvPr>
+          <p:cNvPicPr>
+            <a:picLocks noChangeAspect="1"/>
+          </p:cNvPicPr>
+          <p:nvPr/>
+        </p:nvPicPr>
+        <p:blipFill>
+          <a:blip r:embed="rId2"/>
+          <a:stretch>
+            <a:fillRect/>
+          </a:stretch>
+        </p:blipFill>
+        <p:spPr>
+          <a:xfrm>
+            <a:off x="6947198" y="0"/>
+            <a:ext cx="5244802" cy="6858000"/>
+          </a:xfrm>
+          <a:prstGeom prst="rect">
+            <a:avLst/>
+          </a:prstGeom>
+        </p:spPr>
+      </p:pic>
+    </p:spTree>
+    <p:extLst>
+      <p:ext uri="{BB962C8B-B14F-4D97-AF65-F5344CB8AC3E}">
+        <p14:creationId xmlns:p14="http://schemas.microsoft.com/office/powerpoint/2010/main" val="2172185051"/>
+      </p:ext>
+    </p:extLst>
+  </p:cSld>
+  <p:clrMapOvr>
+    <a:masterClrMapping/>
+  </p:clrMapOvr>
+</p:sld>
+</file>
+
+<file path=ppt/slides/slide4.xml><?xml version="1.0" encoding="utf-8"?>
+<p:sld xmlns:a="http://schemas.openxmlformats.org/drawingml/2006/main" xmlns:r="http://schemas.openxmlformats.org/officeDocument/2006/relationships" xmlns:p="http://schemas.openxmlformats.org/presentationml/2006/main">
+  <p:cSld>
+    <p:spTree>
+      <p:nvGrpSpPr>
+        <p:cNvPr id="1" name="">
+          <a:extLst>
+            <a:ext uri="{FF2B5EF4-FFF2-40B4-BE49-F238E27FC236}">
+              <a16:creationId xmlns:a16="http://schemas.microsoft.com/office/drawing/2014/main" id="{62D17AC2-CC07-1F10-A2AB-D6893B454467}"/>
+            </a:ext>
+          </a:extLst>
+        </p:cNvPr>
+        <p:cNvGrpSpPr/>
+        <p:nvPr/>
+      </p:nvGrpSpPr>
+      <p:grpSpPr>
+        <a:xfrm>
+          <a:off x="0" y="0"/>
+          <a:ext cx="0" cy="0"/>
+          <a:chOff x="0" y="0"/>
+          <a:chExt cx="0" cy="0"/>
+        </a:xfrm>
+      </p:grpSpPr>
+      <p:sp>
+        <p:nvSpPr>
+          <p:cNvPr id="3" name="TextBox 2">
+            <a:extLst>
+              <a:ext uri="{FF2B5EF4-FFF2-40B4-BE49-F238E27FC236}">
+                <a16:creationId xmlns:a16="http://schemas.microsoft.com/office/drawing/2014/main" id="{A9F0863E-F2FB-1788-5C02-8CEF44081E54}"/>
+              </a:ext>
+            </a:extLst>
+          </p:cNvPr>
+          <p:cNvSpPr txBox="1"/>
+          <p:nvPr/>
+        </p:nvSpPr>
+        <p:spPr>
+          <a:xfrm>
+            <a:off x="217714" y="255046"/>
+            <a:ext cx="11756571" cy="355354"/>
+          </a:xfrm>
+          <a:prstGeom prst="rect">
+            <a:avLst/>
+          </a:prstGeom>
+          <a:noFill/>
+        </p:spPr>
+        <p:txBody>
+          <a:bodyPr wrap="square">
+            <a:spAutoFit/>
+          </a:bodyPr>
+          <a:lstStyle/>
+          <a:p>
+            <a:pPr>
+              <a:lnSpc>
+                <a:spcPct val="150000"/>
+              </a:lnSpc>
+              <a:buNone/>
+            </a:pPr>
+            <a:r>
+              <a:rPr kumimoji="0" lang="en-US" altLang="en-US" sz="1300" b="0" i="0" u="none" strike="noStrike" cap="none" normalizeH="0" baseline="0">
+                <a:ln>
+                  <a:noFill/>
+                </a:ln>
+                <a:solidFill>
+                  <a:schemeClr val="tx1"/>
+                </a:solidFill>
+                <a:effectLst/>
+                <a:latin typeface="Arial" panose="020B0604020202020204" pitchFamily="34" charset="0"/>
+              </a:rPr>
+              <a:t>.</a:t>
+            </a:r>
+          </a:p>
+        </p:txBody>
+      </p:sp>
+      <p:pic>
+        <p:nvPicPr>
+          <p:cNvPr id="8" name="Picture 7">
+            <a:extLst>
+              <a:ext uri="{FF2B5EF4-FFF2-40B4-BE49-F238E27FC236}">
+                <a16:creationId xmlns:a16="http://schemas.microsoft.com/office/drawing/2014/main" id="{B8B1A615-E07F-972C-05F9-D79D2128E224}"/>
+              </a:ext>
+            </a:extLst>
+          </p:cNvPr>
+          <p:cNvPicPr>
+            <a:picLocks noChangeAspect="1"/>
+          </p:cNvPicPr>
+          <p:nvPr/>
+        </p:nvPicPr>
+        <p:blipFill>
+          <a:blip r:embed="rId2"/>
+          <a:stretch>
+            <a:fillRect/>
+          </a:stretch>
+        </p:blipFill>
+        <p:spPr>
+          <a:xfrm>
+            <a:off x="0" y="1263946"/>
+            <a:ext cx="12192000" cy="4330108"/>
+          </a:xfrm>
+          <a:prstGeom prst="rect">
+            <a:avLst/>
+          </a:prstGeom>
+          <a:ln w="38100" cap="sq">
+            <a:solidFill>
+              <a:srgbClr val="000000"/>
+            </a:solidFill>
+            <a:prstDash val="solid"/>
+            <a:miter lim="800000"/>
+          </a:ln>
+          <a:effectLst>
+            <a:outerShdw blurRad="50800" dist="38100" dir="2700000" algn="tl" rotWithShape="0">
+              <a:srgbClr val="000000">
+                <a:alpha val="43000"/>
+              </a:srgbClr>
+            </a:outerShdw>
+          </a:effectLst>
+        </p:spPr>
+      </p:pic>
+    </p:spTree>
+    <p:extLst>
+      <p:ext uri="{BB962C8B-B14F-4D97-AF65-F5344CB8AC3E}">
+        <p14:creationId xmlns:p14="http://schemas.microsoft.com/office/powerpoint/2010/main" val="2874585695"/>
+      </p:ext>
+    </p:extLst>
+  </p:cSld>
+  <p:clrMapOvr>
+    <a:masterClrMapping/>
+  </p:clrMapOvr>
+</p:sld>
+</file>
+
+<file path=ppt/slides/slide5.xml><?xml version="1.0" encoding="utf-8"?>
+<p:sld xmlns:a="http://schemas.openxmlformats.org/drawingml/2006/main" xmlns:r="http://schemas.openxmlformats.org/officeDocument/2006/relationships" xmlns:p="http://schemas.openxmlformats.org/presentationml/2006/main">
+  <p:cSld>
+    <p:spTree>
+      <p:nvGrpSpPr>
+        <p:cNvPr id="1" name="">
+          <a:extLst>
+            <a:ext uri="{FF2B5EF4-FFF2-40B4-BE49-F238E27FC236}">
+              <a16:creationId xmlns:a16="http://schemas.microsoft.com/office/drawing/2014/main" id="{21C09EC6-AB16-1FCD-079E-8E2D9AB53922}"/>
+            </a:ext>
+          </a:extLst>
+        </p:cNvPr>
+        <p:cNvGrpSpPr/>
+        <p:nvPr/>
+      </p:nvGrpSpPr>
+      <p:grpSpPr>
+        <a:xfrm>
+          <a:off x="0" y="0"/>
+          <a:ext cx="0" cy="0"/>
+          <a:chOff x="0" y="0"/>
+          <a:chExt cx="0" cy="0"/>
+        </a:xfrm>
+      </p:grpSpPr>
+      <p:sp>
+        <p:nvSpPr>
+          <p:cNvPr id="3" name="TextBox 2">
+            <a:extLst>
+              <a:ext uri="{FF2B5EF4-FFF2-40B4-BE49-F238E27FC236}">
+                <a16:creationId xmlns:a16="http://schemas.microsoft.com/office/drawing/2014/main" id="{8FDC0459-AB28-16F8-40DA-9A8BAB216713}"/>
+              </a:ext>
+            </a:extLst>
+          </p:cNvPr>
+          <p:cNvSpPr txBox="1"/>
+          <p:nvPr/>
+        </p:nvSpPr>
+        <p:spPr>
+          <a:xfrm>
+            <a:off x="217714" y="255046"/>
+            <a:ext cx="11756571" cy="355354"/>
+          </a:xfrm>
+          <a:prstGeom prst="rect">
+            <a:avLst/>
+          </a:prstGeom>
+          <a:noFill/>
+        </p:spPr>
+        <p:txBody>
+          <a:bodyPr wrap="square">
+            <a:spAutoFit/>
+          </a:bodyPr>
+          <a:lstStyle/>
+          <a:p>
+            <a:pPr>
+              <a:lnSpc>
+                <a:spcPct val="150000"/>
+              </a:lnSpc>
+              <a:buNone/>
+            </a:pPr>
+            <a:r>
+              <a:rPr kumimoji="0" lang="en-US" altLang="en-US" sz="1300" b="0" i="0" u="none" strike="noStrike" cap="none" normalizeH="0" baseline="0">
+                <a:ln>
+                  <a:noFill/>
+                </a:ln>
+                <a:solidFill>
+                  <a:schemeClr val="tx1"/>
+                </a:solidFill>
+                <a:effectLst/>
+                <a:latin typeface="Arial" panose="020B0604020202020204" pitchFamily="34" charset="0"/>
+              </a:rPr>
+              <a:t>.</a:t>
+            </a:r>
+          </a:p>
+        </p:txBody>
+      </p:sp>
+    </p:spTree>
+    <p:extLst>
+      <p:ext uri="{BB962C8B-B14F-4D97-AF65-F5344CB8AC3E}">
+        <p14:creationId xmlns:p14="http://schemas.microsoft.com/office/powerpoint/2010/main" val="1532420102"/>
+      </p:ext>
+    </p:extLst>
+  </p:cSld>
+  <p:clrMapOvr>
+    <a:masterClrMapping/>
+  </p:clrMapOvr>
+</p:sld>
+</file>
+
+<file path=ppt/slides/slide6.xml><?xml version="1.0" encoding="utf-8"?>
+<p:sld xmlns:a="http://schemas.openxmlformats.org/drawingml/2006/main" xmlns:r="http://schemas.openxmlformats.org/officeDocument/2006/relationships" xmlns:p="http://schemas.openxmlformats.org/presentationml/2006/main">
+  <p:cSld>
+    <p:spTree>
+      <p:nvGrpSpPr>
+        <p:cNvPr id="1" name="">
+          <a:extLst>
+            <a:ext uri="{FF2B5EF4-FFF2-40B4-BE49-F238E27FC236}">
+              <a16:creationId xmlns:a16="http://schemas.microsoft.com/office/drawing/2014/main" id="{11AD2F6E-3795-7633-F915-844432A024DA}"/>
+            </a:ext>
+          </a:extLst>
+        </p:cNvPr>
+        <p:cNvGrpSpPr/>
+        <p:nvPr/>
+      </p:nvGrpSpPr>
+      <p:grpSpPr>
+        <a:xfrm>
+          <a:off x="0" y="0"/>
+          <a:ext cx="0" cy="0"/>
+          <a:chOff x="0" y="0"/>
+          <a:chExt cx="0" cy="0"/>
+        </a:xfrm>
+      </p:grpSpPr>
+      <p:sp>
+        <p:nvSpPr>
+          <p:cNvPr id="3" name="TextBox 2">
+            <a:extLst>
+              <a:ext uri="{FF2B5EF4-FFF2-40B4-BE49-F238E27FC236}">
+                <a16:creationId xmlns:a16="http://schemas.microsoft.com/office/drawing/2014/main" id="{BED88A2C-DB78-66E1-0D4B-2690B26FE6AE}"/>
+              </a:ext>
+            </a:extLst>
+          </p:cNvPr>
+          <p:cNvSpPr txBox="1"/>
+          <p:nvPr/>
+        </p:nvSpPr>
+        <p:spPr>
+          <a:xfrm>
+            <a:off x="217714" y="255046"/>
+            <a:ext cx="11756571" cy="355354"/>
+          </a:xfrm>
+          <a:prstGeom prst="rect">
+            <a:avLst/>
+          </a:prstGeom>
+          <a:noFill/>
+        </p:spPr>
+        <p:txBody>
+          <a:bodyPr wrap="square">
+            <a:spAutoFit/>
+          </a:bodyPr>
+          <a:lstStyle/>
+          <a:p>
+            <a:pPr>
+              <a:lnSpc>
+                <a:spcPct val="150000"/>
+              </a:lnSpc>
+              <a:buNone/>
+            </a:pPr>
+            <a:r>
+              <a:rPr kumimoji="0" lang="en-US" altLang="en-US" sz="1300" b="0" i="0" u="none" strike="noStrike" cap="none" normalizeH="0" baseline="0">
+                <a:ln>
+                  <a:noFill/>
+                </a:ln>
+                <a:solidFill>
+                  <a:schemeClr val="tx1"/>
+                </a:solidFill>
+                <a:effectLst/>
+                <a:latin typeface="Arial" panose="020B0604020202020204" pitchFamily="34" charset="0"/>
+              </a:rPr>
+              <a:t>.</a:t>
+            </a:r>
+          </a:p>
+        </p:txBody>
+      </p:sp>
+    </p:spTree>
+    <p:extLst>
+      <p:ext uri="{BB962C8B-B14F-4D97-AF65-F5344CB8AC3E}">
+        <p14:creationId xmlns:p14="http://schemas.microsoft.com/office/powerpoint/2010/main" val="266777014"/>
+      </p:ext>
+    </p:extLst>
+  </p:cSld>
+  <p:clrMapOvr>
+    <a:masterClrMapping/>
+  </p:clrMapOvr>
+</p:sld>
+</file>
+
+<file path=ppt/slides/slide7.xml><?xml version="1.0" encoding="utf-8"?>
+<p:sld xmlns:a="http://schemas.openxmlformats.org/drawingml/2006/main" xmlns:r="http://schemas.openxmlformats.org/officeDocument/2006/relationships" xmlns:p="http://schemas.openxmlformats.org/presentationml/2006/main">
+  <p:cSld>
+    <p:spTree>
+      <p:nvGrpSpPr>
+        <p:cNvPr id="1" name="">
+          <a:extLst>
+            <a:ext uri="{FF2B5EF4-FFF2-40B4-BE49-F238E27FC236}">
+              <a16:creationId xmlns:a16="http://schemas.microsoft.com/office/drawing/2014/main" id="{3CEFA217-9B54-AF41-D7C5-B7BD8E6EA94E}"/>
+            </a:ext>
+          </a:extLst>
+        </p:cNvPr>
+        <p:cNvGrpSpPr/>
+        <p:nvPr/>
+      </p:nvGrpSpPr>
+      <p:grpSpPr>
+        <a:xfrm>
+          <a:off x="0" y="0"/>
+          <a:ext cx="0" cy="0"/>
+          <a:chOff x="0" y="0"/>
+          <a:chExt cx="0" cy="0"/>
+        </a:xfrm>
+      </p:grpSpPr>
+      <p:sp>
+        <p:nvSpPr>
+          <p:cNvPr id="3" name="TextBox 2">
+            <a:extLst>
+              <a:ext uri="{FF2B5EF4-FFF2-40B4-BE49-F238E27FC236}">
+                <a16:creationId xmlns:a16="http://schemas.microsoft.com/office/drawing/2014/main" id="{A3A24C15-6CFA-FAD9-0E20-17667D46435B}"/>
+              </a:ext>
+            </a:extLst>
+          </p:cNvPr>
+          <p:cNvSpPr txBox="1"/>
+          <p:nvPr/>
+        </p:nvSpPr>
+        <p:spPr>
+          <a:xfrm>
+            <a:off x="217714" y="255046"/>
+            <a:ext cx="11756571" cy="355354"/>
+          </a:xfrm>
+          <a:prstGeom prst="rect">
+            <a:avLst/>
+          </a:prstGeom>
+          <a:noFill/>
+        </p:spPr>
+        <p:txBody>
+          <a:bodyPr wrap="square">
+            <a:spAutoFit/>
+          </a:bodyPr>
+          <a:lstStyle/>
+          <a:p>
+            <a:pPr>
+              <a:lnSpc>
+                <a:spcPct val="150000"/>
+              </a:lnSpc>
+              <a:buNone/>
+            </a:pPr>
+            <a:r>
+              <a:rPr kumimoji="0" lang="en-US" altLang="en-US" sz="1300" b="0" i="0" u="none" strike="noStrike" cap="none" normalizeH="0" baseline="0">
+                <a:ln>
+                  <a:noFill/>
+                </a:ln>
+                <a:solidFill>
+                  <a:schemeClr val="tx1"/>
+                </a:solidFill>
+                <a:effectLst/>
+                <a:latin typeface="Arial" panose="020B0604020202020204" pitchFamily="34" charset="0"/>
+              </a:rPr>
+              <a:t>.</a:t>
+            </a:r>
+          </a:p>
+        </p:txBody>
+      </p:sp>
+    </p:spTree>
+    <p:extLst>
+      <p:ext uri="{BB962C8B-B14F-4D97-AF65-F5344CB8AC3E}">
+        <p14:creationId xmlns:p14="http://schemas.microsoft.com/office/powerpoint/2010/main" val="3316762690"/>
+      </p:ext>
+    </p:extLst>
+  </p:cSld>
+  <p:clrMapOvr>
+    <a:masterClrMapping/>
+  </p:clrMapOvr>
+</p:sld>
+</file>
+
+<file path=ppt/slides/slide8.xml><?xml version="1.0" encoding="utf-8"?>
 <p:sld xmlns:a="http://schemas.openxmlformats.org/drawingml/2006/main" xmlns:r="http://schemas.openxmlformats.org/officeDocument/2006/relationships" xmlns:p="http://schemas.openxmlformats.org/presentationml/2006/main">
   <p:cSld>
     <p:spTree>

</xml_diff>